<commit_message>
Export PnP and rules to PDF; name files in the print instructions.
</commit_message>
<xml_diff>
--- a/output/svet-moy-zerkalce-card-backs.pptx
+++ b/output/svet-moy-zerkalce-card-backs.pptx
@@ -6,6 +6,7 @@
   </p:sldMasterIdLst>
   <p:sldIdLst>
     <p:sldId id="256" r:id="rId7"/>
+    <p:sldId id="257" r:id="rId8"/>
   </p:sldIdLst>
   <p:sldSz cx="10692000" cy="7560000" type="screen4x3"/>
   <p:notesSz cx="6858000" cy="9144000"/>
@@ -3096,19 +3097,24 @@
         </p:nvSpPr>
         <p:spPr>
           <a:xfrm>
-            <a:off x="8442742" y="693465"/>
-            <a:ext cx="2064494" cy="1597267"/>
+            <a:off x="6930000" y="485999"/>
+            <a:ext cx="3168000" cy="2268000"/>
           </a:xfrm>
+          <a:blipFill>
+            <a:blip r:embed="rId2"/>
+            <a:stretch>
+              <a:fillRect/>
+            </a:stretch>
+          </a:blipFill>
           <a:prstGeom prst="rect">
             <a:avLst/>
           </a:prstGeom>
-          <a:noFill/>
           <a:ln>
             <a:noFill/>
           </a:ln>
         </p:spPr>
         <p:txBody>
-          <a:bodyPr rtlCol="0" anchor="t" wrap="square" lIns="72438" rIns="72438" tIns="57950" bIns="57950"/>
+          <a:bodyPr rtlCol="0" anchor="t" wrap="square" lIns="348480" rIns="348480" tIns="126000" bIns="816480"/>
           <a:lstStyle/>
           <a:p>
             <a:pPr algn="ctr">
@@ -3120,7 +3126,7 @@
               </a:spcAft>
             </a:pPr>
             <a:r>
-              <a:rPr sz="1800" b="1">
+              <a:rPr sz="2000" b="1">
                 <a:solidFill>
                   <a:srgbClr val="1A1A1A"/>
                 </a:solidFill>
@@ -3139,19 +3145,24 @@
         </p:nvSpPr>
         <p:spPr>
           <a:xfrm>
-            <a:off x="6378247" y="693465"/>
-            <a:ext cx="2064494" cy="1597267"/>
+            <a:off x="3762000" y="485999"/>
+            <a:ext cx="3168000" cy="2268000"/>
           </a:xfrm>
+          <a:blipFill>
+            <a:blip r:embed="rId2"/>
+            <a:stretch>
+              <a:fillRect/>
+            </a:stretch>
+          </a:blipFill>
           <a:prstGeom prst="rect">
             <a:avLst/>
           </a:prstGeom>
-          <a:noFill/>
           <a:ln>
             <a:noFill/>
           </a:ln>
         </p:spPr>
         <p:txBody>
-          <a:bodyPr rtlCol="0" anchor="t" wrap="square" lIns="72438" rIns="72438" tIns="57950" bIns="57950"/>
+          <a:bodyPr rtlCol="0" anchor="t" wrap="square" lIns="348480" rIns="348480" tIns="126000" bIns="816480"/>
           <a:lstStyle/>
           <a:p>
             <a:pPr algn="ctr">
@@ -3163,7 +3174,7 @@
               </a:spcAft>
             </a:pPr>
             <a:r>
-              <a:rPr sz="1700" b="1">
+              <a:rPr sz="2000" b="1">
                 <a:solidFill>
                   <a:srgbClr val="1A1A1A"/>
                 </a:solidFill>
@@ -3182,19 +3193,24 @@
         </p:nvSpPr>
         <p:spPr>
           <a:xfrm>
-            <a:off x="4313752" y="693465"/>
-            <a:ext cx="2064494" cy="1597267"/>
+            <a:off x="594000" y="485999"/>
+            <a:ext cx="3168000" cy="2268000"/>
           </a:xfrm>
+          <a:blipFill>
+            <a:blip r:embed="rId2"/>
+            <a:stretch>
+              <a:fillRect/>
+            </a:stretch>
+          </a:blipFill>
           <a:prstGeom prst="rect">
             <a:avLst/>
           </a:prstGeom>
-          <a:noFill/>
           <a:ln>
             <a:noFill/>
           </a:ln>
         </p:spPr>
         <p:txBody>
-          <a:bodyPr rtlCol="0" anchor="t" wrap="square" lIns="72438" rIns="72438" tIns="57950" bIns="57950"/>
+          <a:bodyPr rtlCol="0" anchor="t" wrap="square" lIns="348480" rIns="348480" tIns="126000" bIns="816480"/>
           <a:lstStyle/>
           <a:p>
             <a:pPr algn="ctr">
@@ -3206,7 +3222,7 @@
               </a:spcAft>
             </a:pPr>
             <a:r>
-              <a:rPr sz="1800" b="1">
+              <a:rPr sz="2000" b="1">
                 <a:solidFill>
                   <a:srgbClr val="1A1A1A"/>
                 </a:solidFill>
@@ -3225,19 +3241,24 @@
         </p:nvSpPr>
         <p:spPr>
           <a:xfrm>
-            <a:off x="2249257" y="693465"/>
-            <a:ext cx="2064494" cy="1597267"/>
+            <a:off x="6930000" y="2754000"/>
+            <a:ext cx="3168000" cy="2268000"/>
           </a:xfrm>
+          <a:blipFill>
+            <a:blip r:embed="rId2"/>
+            <a:stretch>
+              <a:fillRect/>
+            </a:stretch>
+          </a:blipFill>
           <a:prstGeom prst="rect">
             <a:avLst/>
           </a:prstGeom>
-          <a:noFill/>
           <a:ln>
             <a:noFill/>
           </a:ln>
         </p:spPr>
         <p:txBody>
-          <a:bodyPr rtlCol="0" anchor="t" wrap="square" lIns="72438" rIns="72438" tIns="57950" bIns="57950"/>
+          <a:bodyPr rtlCol="0" anchor="t" wrap="square" lIns="348480" rIns="348480" tIns="126000" bIns="816480"/>
           <a:lstStyle/>
           <a:p>
             <a:pPr algn="ctr">
@@ -3249,7 +3270,7 @@
               </a:spcAft>
             </a:pPr>
             <a:r>
-              <a:rPr sz="1800" b="1">
+              <a:rPr sz="2000" b="1">
                 <a:solidFill>
                   <a:srgbClr val="1A1A1A"/>
                 </a:solidFill>
@@ -3268,19 +3289,24 @@
         </p:nvSpPr>
         <p:spPr>
           <a:xfrm>
-            <a:off x="184762" y="693465"/>
-            <a:ext cx="2064494" cy="1597267"/>
+            <a:off x="3762000" y="2754000"/>
+            <a:ext cx="3168000" cy="2268000"/>
           </a:xfrm>
+          <a:blipFill>
+            <a:blip r:embed="rId2"/>
+            <a:stretch>
+              <a:fillRect/>
+            </a:stretch>
+          </a:blipFill>
           <a:prstGeom prst="rect">
             <a:avLst/>
           </a:prstGeom>
-          <a:noFill/>
           <a:ln>
             <a:noFill/>
           </a:ln>
         </p:spPr>
         <p:txBody>
-          <a:bodyPr rtlCol="0" anchor="t" wrap="square" lIns="72438" rIns="72438" tIns="57950" bIns="57950"/>
+          <a:bodyPr rtlCol="0" anchor="t" wrap="square" lIns="348480" rIns="348480" tIns="126000" bIns="816480"/>
           <a:lstStyle/>
           <a:p>
             <a:pPr algn="ctr">
@@ -3292,7 +3318,7 @@
               </a:spcAft>
             </a:pPr>
             <a:r>
-              <a:rPr sz="1800" b="1">
+              <a:rPr sz="2000" b="1">
                 <a:solidFill>
                   <a:srgbClr val="1A1A1A"/>
                 </a:solidFill>
@@ -3311,19 +3337,24 @@
         </p:nvSpPr>
         <p:spPr>
           <a:xfrm>
-            <a:off x="8442742" y="2290732"/>
-            <a:ext cx="2064494" cy="1597267"/>
+            <a:off x="594000" y="2754000"/>
+            <a:ext cx="3168000" cy="2268000"/>
           </a:xfrm>
+          <a:blipFill>
+            <a:blip r:embed="rId2"/>
+            <a:stretch>
+              <a:fillRect/>
+            </a:stretch>
+          </a:blipFill>
           <a:prstGeom prst="rect">
             <a:avLst/>
           </a:prstGeom>
-          <a:noFill/>
           <a:ln>
             <a:noFill/>
           </a:ln>
         </p:spPr>
         <p:txBody>
-          <a:bodyPr rtlCol="0" anchor="t" wrap="square" lIns="72438" rIns="72438" tIns="57950" bIns="57950"/>
+          <a:bodyPr rtlCol="0" anchor="t" wrap="square" lIns="348480" rIns="348480" tIns="126000" bIns="816480"/>
           <a:lstStyle/>
           <a:p>
             <a:pPr algn="ctr">
@@ -3335,7 +3366,7 @@
               </a:spcAft>
             </a:pPr>
             <a:r>
-              <a:rPr sz="1800" b="1">
+              <a:rPr sz="2000" b="1">
                 <a:solidFill>
                   <a:srgbClr val="1A1A1A"/>
                 </a:solidFill>
@@ -3354,19 +3385,24 @@
         </p:nvSpPr>
         <p:spPr>
           <a:xfrm>
-            <a:off x="6378247" y="2290732"/>
-            <a:ext cx="2064494" cy="1597267"/>
+            <a:off x="6930000" y="5022000"/>
+            <a:ext cx="3168000" cy="2268000"/>
           </a:xfrm>
+          <a:blipFill>
+            <a:blip r:embed="rId2"/>
+            <a:stretch>
+              <a:fillRect/>
+            </a:stretch>
+          </a:blipFill>
           <a:prstGeom prst="rect">
             <a:avLst/>
           </a:prstGeom>
-          <a:noFill/>
           <a:ln>
             <a:noFill/>
           </a:ln>
         </p:spPr>
         <p:txBody>
-          <a:bodyPr rtlCol="0" anchor="t" wrap="square" lIns="72438" rIns="72438" tIns="57950" bIns="57950"/>
+          <a:bodyPr rtlCol="0" anchor="t" wrap="square" lIns="348480" rIns="348480" tIns="126000" bIns="816480"/>
           <a:lstStyle/>
           <a:p>
             <a:pPr algn="ctr">
@@ -3378,7 +3414,7 @@
               </a:spcAft>
             </a:pPr>
             <a:r>
-              <a:rPr sz="1800" b="1">
+              <a:rPr sz="2000" b="1">
                 <a:solidFill>
                   <a:srgbClr val="1A1A1A"/>
                 </a:solidFill>
@@ -3397,19 +3433,24 @@
         </p:nvSpPr>
         <p:spPr>
           <a:xfrm>
-            <a:off x="4313752" y="2290732"/>
-            <a:ext cx="2064494" cy="1597267"/>
+            <a:off x="3762000" y="5022000"/>
+            <a:ext cx="3168000" cy="2268000"/>
           </a:xfrm>
+          <a:blipFill>
+            <a:blip r:embed="rId2"/>
+            <a:stretch>
+              <a:fillRect/>
+            </a:stretch>
+          </a:blipFill>
           <a:prstGeom prst="rect">
             <a:avLst/>
           </a:prstGeom>
-          <a:noFill/>
           <a:ln>
             <a:noFill/>
           </a:ln>
         </p:spPr>
         <p:txBody>
-          <a:bodyPr rtlCol="0" anchor="t" wrap="square" lIns="72438" rIns="72438" tIns="57950" bIns="57950"/>
+          <a:bodyPr rtlCol="0" anchor="t" wrap="square" lIns="348480" rIns="348480" tIns="126000" bIns="816480"/>
           <a:lstStyle/>
           <a:p>
             <a:pPr algn="ctr">
@@ -3421,7 +3462,7 @@
               </a:spcAft>
             </a:pPr>
             <a:r>
-              <a:rPr sz="1800" b="1">
+              <a:rPr sz="2000" b="1">
                 <a:solidFill>
                   <a:srgbClr val="1A1A1A"/>
                 </a:solidFill>
@@ -3440,19 +3481,24 @@
         </p:nvSpPr>
         <p:spPr>
           <a:xfrm>
-            <a:off x="2249257" y="2290732"/>
-            <a:ext cx="2064494" cy="1597267"/>
+            <a:off x="594000" y="5022000"/>
+            <a:ext cx="3168000" cy="2268000"/>
           </a:xfrm>
+          <a:blipFill>
+            <a:blip r:embed="rId2"/>
+            <a:stretch>
+              <a:fillRect/>
+            </a:stretch>
+          </a:blipFill>
           <a:prstGeom prst="rect">
             <a:avLst/>
           </a:prstGeom>
-          <a:noFill/>
           <a:ln>
             <a:noFill/>
           </a:ln>
         </p:spPr>
         <p:txBody>
-          <a:bodyPr rtlCol="0" anchor="t" wrap="square" lIns="72438" rIns="72438" tIns="57950" bIns="57950"/>
+          <a:bodyPr rtlCol="0" anchor="t" wrap="square" lIns="348480" rIns="348480" tIns="126000" bIns="816480"/>
           <a:lstStyle/>
           <a:p>
             <a:pPr algn="ctr">
@@ -3464,7 +3510,7 @@
               </a:spcAft>
             </a:pPr>
             <a:r>
-              <a:rPr sz="1800" b="1">
+              <a:rPr sz="2000" b="1">
                 <a:solidFill>
                   <a:srgbClr val="1A1A1A"/>
                 </a:solidFill>
@@ -3477,25 +3523,83 @@
       </p:sp>
       <p:sp>
         <p:nvSpPr>
-          <p:cNvPr id="11" name="Rectangle 10"/>
-          <p:cNvSpPr/>
+          <p:cNvPr id="11" name="TextBox 10"/>
+          <p:cNvSpPr txBox="1"/>
           <p:nvPr/>
         </p:nvSpPr>
         <p:spPr>
           <a:xfrm>
-            <a:off x="184762" y="2290732"/>
-            <a:ext cx="2064494" cy="1597267"/>
+            <a:off x="184762" y="184762"/>
+            <a:ext cx="10322475" cy="198000"/>
           </a:xfrm>
           <a:prstGeom prst="rect">
             <a:avLst/>
           </a:prstGeom>
           <a:noFill/>
+        </p:spPr>
+        <p:txBody>
+          <a:bodyPr wrap="none" lIns="0" rIns="0" tIns="0" bIns="0">
+            <a:spAutoFit/>
+          </a:bodyPr>
+          <a:lstStyle/>
+          <a:p>
+            <a:pPr algn="l"/>
+            <a:r>
+              <a:rPr sz="1100" b="1">
+                <a:solidFill>
+                  <a:srgbClr val="1A1A1A"/>
+                </a:solidFill>
+                <a:latin typeface="Arial"/>
+              </a:rPr>
+              <a:t>Карты запросов · ОБОРОТ</a:t>
+            </a:r>
+          </a:p>
+        </p:txBody>
+      </p:sp>
+    </p:spTree>
+  </p:cSld>
+  <p:clrMapOvr>
+    <a:masterClrMapping/>
+  </p:clrMapOvr>
+</p:sld>
+</file>
+
+<file path=ppt/slides/slide2.xml><?xml version="1.0" encoding="utf-8"?>
+<p:sld xmlns:a="http://schemas.openxmlformats.org/drawingml/2006/main" xmlns:p="http://schemas.openxmlformats.org/presentationml/2006/main" xmlns:r="http://schemas.openxmlformats.org/officeDocument/2006/relationships">
+  <p:cSld>
+    <p:spTree>
+      <p:nvGrpSpPr>
+        <p:cNvPr id="1" name=""/>
+        <p:cNvGrpSpPr/>
+        <p:nvPr/>
+      </p:nvGrpSpPr>
+      <p:grpSpPr/>
+      <p:sp>
+        <p:nvSpPr>
+          <p:cNvPr id="2" name="Rectangle 1"/>
+          <p:cNvSpPr/>
+          <p:nvPr/>
+        </p:nvSpPr>
+        <p:spPr>
+          <a:xfrm>
+            <a:off x="6930000" y="485999"/>
+            <a:ext cx="3168000" cy="2268000"/>
+          </a:xfrm>
+          <a:blipFill>
+            <a:blip r:embed="rId2"/>
+            <a:stretch>
+              <a:fillRect/>
+            </a:stretch>
+          </a:blipFill>
+          <a:prstGeom prst="rect">
+            <a:avLst/>
+          </a:prstGeom>
           <a:ln>
             <a:noFill/>
           </a:ln>
         </p:spPr>
         <p:txBody>
-          <a:bodyPr rtlCol="0" anchor="t" wrap="square" lIns="72438" rIns="72438" tIns="57950" bIns="57950"/>
+          <a:bodyPr rtlCol="0" anchor="t" wrap="square" lIns="348480" rIns="348480" tIns="126000" bIns="816480"/>
           <a:lstStyle/>
           <a:p>
             <a:pPr algn="ctr">
@@ -3507,7 +3611,7 @@
               </a:spcAft>
             </a:pPr>
             <a:r>
-              <a:rPr sz="1800" b="1">
+              <a:rPr sz="2000" b="1">
                 <a:solidFill>
                   <a:srgbClr val="1A1A1A"/>
                 </a:solidFill>
@@ -3520,25 +3624,30 @@
       </p:sp>
       <p:sp>
         <p:nvSpPr>
-          <p:cNvPr id="12" name="Rectangle 11"/>
+          <p:cNvPr id="3" name="Rectangle 2"/>
           <p:cNvSpPr/>
           <p:nvPr/>
         </p:nvSpPr>
         <p:spPr>
           <a:xfrm>
-            <a:off x="8442742" y="3888000"/>
-            <a:ext cx="2064494" cy="1597267"/>
+            <a:off x="3762000" y="485999"/>
+            <a:ext cx="3168000" cy="2268000"/>
           </a:xfrm>
+          <a:blipFill>
+            <a:blip r:embed="rId2"/>
+            <a:stretch>
+              <a:fillRect/>
+            </a:stretch>
+          </a:blipFill>
           <a:prstGeom prst="rect">
             <a:avLst/>
           </a:prstGeom>
-          <a:noFill/>
           <a:ln>
             <a:noFill/>
           </a:ln>
         </p:spPr>
         <p:txBody>
-          <a:bodyPr rtlCol="0" anchor="t" wrap="square" lIns="72438" rIns="72438" tIns="57950" bIns="57950"/>
+          <a:bodyPr rtlCol="0" anchor="t" wrap="square" lIns="348480" rIns="348480" tIns="126000" bIns="816480"/>
           <a:lstStyle/>
           <a:p>
             <a:pPr algn="ctr">
@@ -3550,7 +3659,7 @@
               </a:spcAft>
             </a:pPr>
             <a:r>
-              <a:rPr sz="1800" b="1">
+              <a:rPr sz="2000" b="1">
                 <a:solidFill>
                   <a:srgbClr val="1A1A1A"/>
                 </a:solidFill>
@@ -3563,25 +3672,30 @@
       </p:sp>
       <p:sp>
         <p:nvSpPr>
-          <p:cNvPr id="13" name="Rectangle 12"/>
+          <p:cNvPr id="4" name="Rectangle 3"/>
           <p:cNvSpPr/>
           <p:nvPr/>
         </p:nvSpPr>
         <p:spPr>
           <a:xfrm>
-            <a:off x="6378247" y="3888000"/>
-            <a:ext cx="2064494" cy="1597267"/>
+            <a:off x="594000" y="485999"/>
+            <a:ext cx="3168000" cy="2268000"/>
           </a:xfrm>
+          <a:blipFill>
+            <a:blip r:embed="rId2"/>
+            <a:stretch>
+              <a:fillRect/>
+            </a:stretch>
+          </a:blipFill>
           <a:prstGeom prst="rect">
             <a:avLst/>
           </a:prstGeom>
-          <a:noFill/>
           <a:ln>
             <a:noFill/>
           </a:ln>
         </p:spPr>
         <p:txBody>
-          <a:bodyPr rtlCol="0" anchor="t" wrap="square" lIns="72438" rIns="72438" tIns="57950" bIns="57950"/>
+          <a:bodyPr rtlCol="0" anchor="t" wrap="square" lIns="348480" rIns="348480" tIns="126000" bIns="816480"/>
           <a:lstStyle/>
           <a:p>
             <a:pPr algn="ctr">
@@ -3593,7 +3707,7 @@
               </a:spcAft>
             </a:pPr>
             <a:r>
-              <a:rPr sz="1800" b="1">
+              <a:rPr sz="2000" b="1">
                 <a:solidFill>
                   <a:srgbClr val="1A1A1A"/>
                 </a:solidFill>
@@ -3606,25 +3720,30 @@
       </p:sp>
       <p:sp>
         <p:nvSpPr>
-          <p:cNvPr id="14" name="Rectangle 13"/>
+          <p:cNvPr id="5" name="Rectangle 4"/>
           <p:cNvSpPr/>
           <p:nvPr/>
         </p:nvSpPr>
         <p:spPr>
           <a:xfrm>
-            <a:off x="4313752" y="3888000"/>
-            <a:ext cx="2064494" cy="1597267"/>
+            <a:off x="6930000" y="2754000"/>
+            <a:ext cx="3168000" cy="2268000"/>
           </a:xfrm>
+          <a:blipFill>
+            <a:blip r:embed="rId2"/>
+            <a:stretch>
+              <a:fillRect/>
+            </a:stretch>
+          </a:blipFill>
           <a:prstGeom prst="rect">
             <a:avLst/>
           </a:prstGeom>
-          <a:noFill/>
           <a:ln>
             <a:noFill/>
           </a:ln>
         </p:spPr>
         <p:txBody>
-          <a:bodyPr rtlCol="0" anchor="t" wrap="square" lIns="72438" rIns="72438" tIns="57950" bIns="57950"/>
+          <a:bodyPr rtlCol="0" anchor="t" wrap="square" lIns="348480" rIns="348480" tIns="126000" bIns="816480"/>
           <a:lstStyle/>
           <a:p>
             <a:pPr algn="ctr">
@@ -3636,7 +3755,7 @@
               </a:spcAft>
             </a:pPr>
             <a:r>
-              <a:rPr sz="1800" b="1">
+              <a:rPr sz="2000" b="1">
                 <a:solidFill>
                   <a:srgbClr val="1A1A1A"/>
                 </a:solidFill>
@@ -3649,25 +3768,30 @@
       </p:sp>
       <p:sp>
         <p:nvSpPr>
-          <p:cNvPr id="15" name="Rectangle 14"/>
+          <p:cNvPr id="6" name="Rectangle 5"/>
           <p:cNvSpPr/>
           <p:nvPr/>
         </p:nvSpPr>
         <p:spPr>
           <a:xfrm>
-            <a:off x="2249257" y="3888000"/>
-            <a:ext cx="2064494" cy="1597267"/>
+            <a:off x="3762000" y="2754000"/>
+            <a:ext cx="3168000" cy="2268000"/>
           </a:xfrm>
+          <a:blipFill>
+            <a:blip r:embed="rId2"/>
+            <a:stretch>
+              <a:fillRect/>
+            </a:stretch>
+          </a:blipFill>
           <a:prstGeom prst="rect">
             <a:avLst/>
           </a:prstGeom>
-          <a:noFill/>
           <a:ln>
             <a:noFill/>
           </a:ln>
         </p:spPr>
         <p:txBody>
-          <a:bodyPr rtlCol="0" anchor="t" wrap="square" lIns="72438" rIns="72438" tIns="57950" bIns="57950"/>
+          <a:bodyPr rtlCol="0" anchor="t" wrap="square" lIns="348480" rIns="348480" tIns="126000" bIns="816480"/>
           <a:lstStyle/>
           <a:p>
             <a:pPr algn="ctr">
@@ -3679,7 +3803,7 @@
               </a:spcAft>
             </a:pPr>
             <a:r>
-              <a:rPr sz="1800" b="1">
+              <a:rPr sz="2000" b="1">
                 <a:solidFill>
                   <a:srgbClr val="1A1A1A"/>
                 </a:solidFill>
@@ -3692,7 +3816,7 @@
       </p:sp>
       <p:sp>
         <p:nvSpPr>
-          <p:cNvPr id="16" name="TextBox 15"/>
+          <p:cNvPr id="7" name="TextBox 6"/>
           <p:cNvSpPr txBox="1"/>
           <p:nvPr/>
         </p:nvSpPr>

</xml_diff>